<commit_message>
docs: update README, docs site, and PPTX with batched benchmark results
- README: 9x throughput table (1/4/8/16 concurrent requests), updated stats
- docs/index.html: new benchmark section with batched throughput table,
  hero badges updated (4,015 LOC, 262 tests, 9x speedup)
- PPTX: rebuilt with benchmark table, 5 stat boxes, updated architecture
  tree including hf_adapter.py and continuous batching

Co-Authored-By: Claude Opus 4.6 (1M context) <noreply@anthropic.com>
</commit_message>
<xml_diff>
--- a/docs/tiny-trtllm-summary.pptx
+++ b/docs/tiny-trtllm-summary.pptx
@@ -3104,8 +3104,8 @@
         </p:nvSpPr>
         <p:spPr>
           <a:xfrm>
-            <a:off x="731520" y="365760"/>
-            <a:ext cx="12801600" cy="1097280"/>
+            <a:off x="731520" y="274320"/>
+            <a:ext cx="12801600" cy="914400"/>
           </a:xfrm>
           <a:prstGeom prst="rect">
             <a:avLst/>
@@ -3119,7 +3119,7 @@
           <a:lstStyle/>
           <a:p>
             <a:r>
-              <a:rPr sz="5200" b="1">
+              <a:rPr sz="4800" b="1">
                 <a:solidFill>
                   <a:srgbClr val="E6EDF3"/>
                 </a:solidFill>
@@ -3127,7 +3127,7 @@
               <a:t>tiny-</a:t>
             </a:r>
             <a:r>
-              <a:rPr sz="5200" b="1">
+              <a:rPr sz="4800" b="1">
                 <a:solidFill>
                   <a:srgbClr val="58A6FF"/>
                 </a:solidFill>
@@ -3145,8 +3145,8 @@
         </p:nvSpPr>
         <p:spPr>
           <a:xfrm>
-            <a:off x="731520" y="1280160"/>
-            <a:ext cx="12801600" cy="548640"/>
+            <a:off x="731520" y="1097280"/>
+            <a:ext cx="12801600" cy="457200"/>
           </a:xfrm>
           <a:prstGeom prst="rect">
             <a:avLst/>
@@ -3160,12 +3160,12 @@
           <a:lstStyle/>
           <a:p>
             <a:r>
-              <a:rPr sz="1800">
+              <a:rPr sz="1600">
                 <a:solidFill>
                   <a:srgbClr val="8B949E"/>
                 </a:solidFill>
               </a:rPr>
-              <a:t>Minimal reimplementation of TensorRT-LLM's PyTorch backend  |  ~3,700 LOC  |  206 tests  |  86% coverage  |  0 C++ files</a:t>
+              <a:t>Minimal reimplementation of TensorRT-LLM's PyTorch backend  |  ~4K LOC  |  262 tests  |  86% coverage  |  0 C++  |  9x batched speedup</a:t>
             </a:r>
           </a:p>
         </p:txBody>
@@ -3178,7 +3178,7 @@
         </p:nvSpPr>
         <p:spPr>
           <a:xfrm>
-            <a:off x="731520" y="1920240"/>
+            <a:off x="731520" y="1691640"/>
             <a:ext cx="13167360" cy="25400"/>
           </a:xfrm>
           <a:prstGeom prst="rect">
@@ -3221,8 +3221,8 @@
         </p:nvSpPr>
         <p:spPr>
           <a:xfrm>
-            <a:off x="731520" y="2194560"/>
-            <a:ext cx="6400800" cy="457200"/>
+            <a:off x="731520" y="1828800"/>
+            <a:ext cx="6400800" cy="365760"/>
           </a:xfrm>
           <a:prstGeom prst="rect">
             <a:avLst/>
@@ -3236,12 +3236,12 @@
           <a:lstStyle/>
           <a:p>
             <a:r>
-              <a:rPr sz="2200" b="1">
+              <a:rPr sz="2000" b="1">
                 <a:solidFill>
                   <a:srgbClr val="7EE787"/>
                 </a:solidFill>
               </a:rPr>
-              <a:t>16 Core Architectural Differentiators Preserved</a:t>
+              <a:t>16 Core Architectural Differentiators</a:t>
             </a:r>
           </a:p>
         </p:txBody>
@@ -3254,8 +3254,8 @@
         </p:nvSpPr>
         <p:spPr>
           <a:xfrm>
-            <a:off x="731520" y="2743200"/>
-            <a:ext cx="6400800" cy="274320"/>
+            <a:off x="731520" y="2286000"/>
+            <a:ext cx="6400800" cy="228600"/>
           </a:xfrm>
           <a:prstGeom prst="rect">
             <a:avLst/>
@@ -3269,7 +3269,7 @@
           <a:lstStyle/>
           <a:p>
             <a:r>
-              <a:rPr sz="1400" b="1">
+              <a:rPr sz="1300" b="1">
                 <a:solidFill>
                   <a:srgbClr val="58A6FF"/>
                 </a:solidFill>
@@ -3287,8 +3287,8 @@
         </p:nvSpPr>
         <p:spPr>
           <a:xfrm>
-            <a:off x="914400" y="3017520"/>
-            <a:ext cx="6217920" cy="228600"/>
+            <a:off x="868680" y="2514600"/>
+            <a:ext cx="6217920" cy="201168"/>
           </a:xfrm>
           <a:prstGeom prst="rect">
             <a:avLst/>
@@ -3302,7 +3302,7 @@
           <a:lstStyle/>
           <a:p>
             <a:r>
-              <a:rPr sz="1200">
+              <a:rPr sz="1100">
                 <a:solidFill>
                   <a:srgbClr val="8B949E"/>
                 </a:solidFill>
@@ -3320,8 +3320,8 @@
         </p:nvSpPr>
         <p:spPr>
           <a:xfrm>
-            <a:off x="914400" y="3246120"/>
-            <a:ext cx="6217920" cy="228600"/>
+            <a:off x="868680" y="2715768"/>
+            <a:ext cx="6217920" cy="201168"/>
           </a:xfrm>
           <a:prstGeom prst="rect">
             <a:avLst/>
@@ -3335,7 +3335,7 @@
           <a:lstStyle/>
           <a:p>
             <a:r>
-              <a:rPr sz="1200">
+              <a:rPr sz="1100">
                 <a:solidFill>
                   <a:srgbClr val="8B949E"/>
                 </a:solidFill>
@@ -3353,8 +3353,8 @@
         </p:nvSpPr>
         <p:spPr>
           <a:xfrm>
-            <a:off x="914400" y="3474720"/>
-            <a:ext cx="6217920" cy="228600"/>
+            <a:off x="868680" y="2916936"/>
+            <a:ext cx="6217920" cy="201168"/>
           </a:xfrm>
           <a:prstGeom prst="rect">
             <a:avLst/>
@@ -3368,7 +3368,7 @@
           <a:lstStyle/>
           <a:p>
             <a:r>
-              <a:rPr sz="1200">
+              <a:rPr sz="1100">
                 <a:solidFill>
                   <a:srgbClr val="8B949E"/>
                 </a:solidFill>
@@ -3386,8 +3386,8 @@
         </p:nvSpPr>
         <p:spPr>
           <a:xfrm>
-            <a:off x="914400" y="3703320"/>
-            <a:ext cx="6217920" cy="228600"/>
+            <a:off x="868680" y="3118104"/>
+            <a:ext cx="6217920" cy="201168"/>
           </a:xfrm>
           <a:prstGeom prst="rect">
             <a:avLst/>
@@ -3401,7 +3401,7 @@
           <a:lstStyle/>
           <a:p>
             <a:r>
-              <a:rPr sz="1200">
+              <a:rPr sz="1100">
                 <a:solidFill>
                   <a:srgbClr val="8B949E"/>
                 </a:solidFill>
@@ -3419,8 +3419,8 @@
         </p:nvSpPr>
         <p:spPr>
           <a:xfrm>
-            <a:off x="914400" y="3931920"/>
-            <a:ext cx="6217920" cy="228600"/>
+            <a:off x="868680" y="3319272"/>
+            <a:ext cx="6217920" cy="201168"/>
           </a:xfrm>
           <a:prstGeom prst="rect">
             <a:avLst/>
@@ -3434,7 +3434,7 @@
           <a:lstStyle/>
           <a:p>
             <a:r>
-              <a:rPr sz="1200">
+              <a:rPr sz="1100">
                 <a:solidFill>
                   <a:srgbClr val="8B949E"/>
                 </a:solidFill>
@@ -3452,8 +3452,8 @@
         </p:nvSpPr>
         <p:spPr>
           <a:xfrm>
-            <a:off x="914400" y="4160520"/>
-            <a:ext cx="6217920" cy="228600"/>
+            <a:off x="868680" y="3520440"/>
+            <a:ext cx="6217920" cy="201168"/>
           </a:xfrm>
           <a:prstGeom prst="rect">
             <a:avLst/>
@@ -3467,12 +3467,12 @@
           <a:lstStyle/>
           <a:p>
             <a:r>
-              <a:rPr sz="1200">
+              <a:rPr sz="1100">
                 <a:solidFill>
                   <a:srgbClr val="8B949E"/>
                 </a:solidFill>
               </a:rPr>
-              <a:t>  Async two-phase sampling</a:t>
+              <a:t>  Async two-phase sampling + grouped strategies</a:t>
             </a:r>
           </a:p>
         </p:txBody>
@@ -3485,8 +3485,8 @@
         </p:nvSpPr>
         <p:spPr>
           <a:xfrm>
-            <a:off x="914400" y="4389120"/>
-            <a:ext cx="6217920" cy="228600"/>
+            <a:off x="868680" y="3721608"/>
+            <a:ext cx="6217920" cy="201168"/>
           </a:xfrm>
           <a:prstGeom prst="rect">
             <a:avLst/>
@@ -3500,12 +3500,12 @@
           <a:lstStyle/>
           <a:p>
             <a:r>
-              <a:rPr sz="1200">
+              <a:rPr sz="1100">
                 <a:solidFill>
                   <a:srgbClr val="8B949E"/>
                 </a:solidFill>
               </a:rPr>
-              <a:t>  Grouped strategy sampling</a:t>
+              <a:t>  Overlap executor (CPU/GPU ping-pong)</a:t>
             </a:r>
           </a:p>
         </p:txBody>
@@ -3518,8 +3518,8 @@
         </p:nvSpPr>
         <p:spPr>
           <a:xfrm>
-            <a:off x="914400" y="4617720"/>
-            <a:ext cx="6217920" cy="228600"/>
+            <a:off x="868680" y="3922776"/>
+            <a:ext cx="6217920" cy="201168"/>
           </a:xfrm>
           <a:prstGeom prst="rect">
             <a:avLst/>
@@ -3533,12 +3533,12 @@
           <a:lstStyle/>
           <a:p>
             <a:r>
-              <a:rPr sz="1200">
+              <a:rPr sz="1100">
                 <a:solidFill>
                   <a:srgbClr val="8B949E"/>
                 </a:solidFill>
               </a:rPr>
-              <a:t>  Overlap executor (CPU/GPU ping-pong)</a:t>
+              <a:t>  Await-responses (threading.Condition)</a:t>
             </a:r>
           </a:p>
         </p:txBody>
@@ -3551,8 +3551,8 @@
         </p:nvSpPr>
         <p:spPr>
           <a:xfrm>
-            <a:off x="914400" y="4846320"/>
-            <a:ext cx="6217920" cy="228600"/>
+            <a:off x="868680" y="4123944"/>
+            <a:ext cx="6217920" cy="201168"/>
           </a:xfrm>
           <a:prstGeom prst="rect">
             <a:avLst/>
@@ -3566,12 +3566,12 @@
           <a:lstStyle/>
           <a:p>
             <a:r>
-              <a:rPr sz="1200">
+              <a:rPr sz="1100">
                 <a:solidFill>
                   <a:srgbClr val="8B949E"/>
                 </a:solidFill>
               </a:rPr>
-              <a:t>  Await-responses (threading.Condition)</a:t>
+              <a:t>  Batched KV-cached inference (continuous batching)</a:t>
             </a:r>
           </a:p>
         </p:txBody>
@@ -3584,8 +3584,8 @@
         </p:nvSpPr>
         <p:spPr>
           <a:xfrm>
-            <a:off x="731520" y="5166360"/>
-            <a:ext cx="6400800" cy="274320"/>
+            <a:off x="731520" y="4398264"/>
+            <a:ext cx="6400800" cy="228600"/>
           </a:xfrm>
           <a:prstGeom prst="rect">
             <a:avLst/>
@@ -3599,7 +3599,7 @@
           <a:lstStyle/>
           <a:p>
             <a:r>
-              <a:rPr sz="1400" b="1">
+              <a:rPr sz="1300" b="1">
                 <a:solidFill>
                   <a:srgbClr val="58A6FF"/>
                 </a:solidFill>
@@ -3617,8 +3617,8 @@
         </p:nvSpPr>
         <p:spPr>
           <a:xfrm>
-            <a:off x="914400" y="5440680"/>
-            <a:ext cx="6217920" cy="228600"/>
+            <a:off x="868680" y="4626864"/>
+            <a:ext cx="6217920" cy="201168"/>
           </a:xfrm>
           <a:prstGeom prst="rect">
             <a:avLst/>
@@ -3632,7 +3632,7 @@
           <a:lstStyle/>
           <a:p>
             <a:r>
-              <a:rPr sz="1200">
+              <a:rPr sz="1100">
                 <a:solidFill>
                   <a:srgbClr val="8B949E"/>
                 </a:solidFill>
@@ -3650,8 +3650,8 @@
         </p:nvSpPr>
         <p:spPr>
           <a:xfrm>
-            <a:off x="914400" y="5669280"/>
-            <a:ext cx="6217920" cy="228600"/>
+            <a:off x="868680" y="4828032"/>
+            <a:ext cx="6217920" cy="201168"/>
           </a:xfrm>
           <a:prstGeom prst="rect">
             <a:avLst/>
@@ -3665,7 +3665,7 @@
           <a:lstStyle/>
           <a:p>
             <a:r>
-              <a:rPr sz="1200">
+              <a:rPr sz="1100">
                 <a:solidFill>
                   <a:srgbClr val="8B949E"/>
                 </a:solidFill>
@@ -3683,8 +3683,8 @@
         </p:nvSpPr>
         <p:spPr>
           <a:xfrm>
-            <a:off x="914400" y="5897880"/>
-            <a:ext cx="6217920" cy="228600"/>
+            <a:off x="868680" y="5029200"/>
+            <a:ext cx="6217920" cy="201168"/>
           </a:xfrm>
           <a:prstGeom prst="rect">
             <a:avLst/>
@@ -3698,7 +3698,7 @@
           <a:lstStyle/>
           <a:p>
             <a:r>
-              <a:rPr sz="1200">
+              <a:rPr sz="1100">
                 <a:solidFill>
                   <a:srgbClr val="8B949E"/>
                 </a:solidFill>
@@ -3716,8 +3716,8 @@
         </p:nvSpPr>
         <p:spPr>
           <a:xfrm>
-            <a:off x="914400" y="6126480"/>
-            <a:ext cx="6217920" cy="228600"/>
+            <a:off x="868680" y="5230368"/>
+            <a:ext cx="6217920" cy="201168"/>
           </a:xfrm>
           <a:prstGeom prst="rect">
             <a:avLst/>
@@ -3731,7 +3731,7 @@
           <a:lstStyle/>
           <a:p>
             <a:r>
-              <a:rPr sz="1200">
+              <a:rPr sz="1100">
                 <a:solidFill>
                   <a:srgbClr val="8B949E"/>
                 </a:solidFill>
@@ -3749,8 +3749,8 @@
         </p:nvSpPr>
         <p:spPr>
           <a:xfrm>
-            <a:off x="731520" y="6446520"/>
-            <a:ext cx="6400800" cy="274320"/>
+            <a:off x="731520" y="5504688"/>
+            <a:ext cx="6400800" cy="228600"/>
           </a:xfrm>
           <a:prstGeom prst="rect">
             <a:avLst/>
@@ -3764,7 +3764,7 @@
           <a:lstStyle/>
           <a:p>
             <a:r>
-              <a:rPr sz="1400" b="1">
+              <a:rPr sz="1300" b="1">
                 <a:solidFill>
                   <a:srgbClr val="58A6FF"/>
                 </a:solidFill>
@@ -3782,8 +3782,8 @@
         </p:nvSpPr>
         <p:spPr>
           <a:xfrm>
-            <a:off x="914400" y="6720840"/>
-            <a:ext cx="6217920" cy="228600"/>
+            <a:off x="868680" y="5733288"/>
+            <a:ext cx="6217920" cy="201168"/>
           </a:xfrm>
           <a:prstGeom prst="rect">
             <a:avLst/>
@@ -3797,7 +3797,7 @@
           <a:lstStyle/>
           <a:p>
             <a:r>
-              <a:rPr sz="1200">
+              <a:rPr sz="1100">
                 <a:solidFill>
                   <a:srgbClr val="8B949E"/>
                 </a:solidFill>
@@ -3815,8 +3815,8 @@
         </p:nvSpPr>
         <p:spPr>
           <a:xfrm>
-            <a:off x="914400" y="6949440"/>
-            <a:ext cx="6217920" cy="228600"/>
+            <a:off x="868680" y="5934456"/>
+            <a:ext cx="6217920" cy="201168"/>
           </a:xfrm>
           <a:prstGeom prst="rect">
             <a:avLst/>
@@ -3830,7 +3830,7 @@
           <a:lstStyle/>
           <a:p>
             <a:r>
-              <a:rPr sz="1200">
+              <a:rPr sz="1100">
                 <a:solidFill>
                   <a:srgbClr val="8B949E"/>
                 </a:solidFill>
@@ -3848,8 +3848,8 @@
         </p:nvSpPr>
         <p:spPr>
           <a:xfrm>
-            <a:off x="914400" y="7178040"/>
-            <a:ext cx="6217920" cy="228600"/>
+            <a:off x="868680" y="6135624"/>
+            <a:ext cx="6217920" cy="201168"/>
           </a:xfrm>
           <a:prstGeom prst="rect">
             <a:avLst/>
@@ -3863,7 +3863,7 @@
           <a:lstStyle/>
           <a:p>
             <a:r>
-              <a:rPr sz="1200">
+              <a:rPr sz="1100">
                 <a:solidFill>
                   <a:srgbClr val="8B949E"/>
                 </a:solidFill>
@@ -3881,8 +3881,8 @@
         </p:nvSpPr>
         <p:spPr>
           <a:xfrm>
-            <a:off x="7772400" y="2194560"/>
-            <a:ext cx="6400800" cy="457200"/>
+            <a:off x="7772400" y="1828800"/>
+            <a:ext cx="6400800" cy="365760"/>
           </a:xfrm>
           <a:prstGeom prst="rect">
             <a:avLst/>
@@ -3896,7 +3896,7 @@
           <a:lstStyle/>
           <a:p>
             <a:r>
-              <a:rPr sz="2200" b="1">
+              <a:rPr sz="2000" b="1">
                 <a:solidFill>
                   <a:srgbClr val="D2A8FF"/>
                 </a:solidFill>
@@ -3914,8 +3914,8 @@
         </p:nvSpPr>
         <p:spPr>
           <a:xfrm>
-            <a:off x="7772400" y="2743200"/>
-            <a:ext cx="6400800" cy="3200400"/>
+            <a:off x="7772400" y="2286000"/>
+            <a:ext cx="6400800" cy="2743200"/>
           </a:xfrm>
           <a:prstGeom prst="rect">
             <a:avLst/>
@@ -3930,7 +3930,7 @@
           <a:p/>
           <a:p>
             <a:r>
-              <a:rPr sz="1100">
+              <a:rPr sz="1000">
                 <a:solidFill>
                   <a:srgbClr val="8B949E"/>
                 </a:solidFill>
@@ -3941,7 +3941,7 @@
           </a:p>
           <a:p>
             <a:r>
-              <a:rPr sz="1100">
+              <a:rPr sz="1000">
                 <a:solidFill>
                   <a:srgbClr val="8B949E"/>
                 </a:solidFill>
@@ -3952,7 +3952,7 @@
           </a:p>
           <a:p>
             <a:r>
-              <a:rPr sz="1100">
+              <a:rPr sz="1000">
                 <a:solidFill>
                   <a:srgbClr val="8B949E"/>
                 </a:solidFill>
@@ -3963,7 +3963,7 @@
           </a:p>
           <a:p>
             <a:r>
-              <a:rPr sz="1100">
+              <a:rPr sz="1000">
                 <a:solidFill>
                   <a:srgbClr val="8B949E"/>
                 </a:solidFill>
@@ -3974,7 +3974,7 @@
           </a:p>
           <a:p>
             <a:r>
-              <a:rPr sz="1100">
+              <a:rPr sz="1000">
                 <a:solidFill>
                   <a:srgbClr val="8B949E"/>
                 </a:solidFill>
@@ -3985,7 +3985,7 @@
           </a:p>
           <a:p>
             <a:r>
-              <a:rPr sz="1100">
+              <a:rPr sz="1000">
                 <a:solidFill>
                   <a:srgbClr val="8B949E"/>
                 </a:solidFill>
@@ -3996,18 +3996,29 @@
           </a:p>
           <a:p>
             <a:r>
-              <a:rPr sz="1100">
+              <a:rPr sz="1000">
                 <a:solidFill>
                   <a:srgbClr val="8B949E"/>
                 </a:solidFill>
                 <a:latin typeface="Courier New"/>
               </a:rPr>
+              <a:t>    hf_adapter.py    Batched KV-cache adapter</a:t>
+            </a:r>
+          </a:p>
+          <a:p>
+            <a:r>
+              <a:rPr sz="1000">
+                <a:solidFill>
+                  <a:srgbClr val="8B949E"/>
+                </a:solidFill>
+                <a:latin typeface="Courier New"/>
+              </a:rPr>
               <a:t>    sampler.py       Async two-phase</a:t>
             </a:r>
           </a:p>
           <a:p>
             <a:r>
-              <a:rPr sz="1100">
+              <a:rPr sz="1000">
                 <a:solidFill>
                   <a:srgbClr val="8B949E"/>
                 </a:solidFill>
@@ -4018,7 +4029,7 @@
           </a:p>
           <a:p>
             <a:r>
-              <a:rPr sz="1100">
+              <a:rPr sz="1000">
                 <a:solidFill>
                   <a:srgbClr val="8B949E"/>
                 </a:solidFill>
@@ -4029,7 +4040,7 @@
           </a:p>
           <a:p>
             <a:r>
-              <a:rPr sz="1100">
+              <a:rPr sz="1000">
                 <a:solidFill>
                   <a:srgbClr val="8B949E"/>
                 </a:solidFill>
@@ -4040,7 +4051,7 @@
           </a:p>
           <a:p>
             <a:r>
-              <a:rPr sz="1100">
+              <a:rPr sz="1000">
                 <a:solidFill>
                   <a:srgbClr val="8B949E"/>
                 </a:solidFill>
@@ -4051,7 +4062,7 @@
           </a:p>
           <a:p>
             <a:r>
-              <a:rPr sz="1100">
+              <a:rPr sz="1000">
                 <a:solidFill>
                   <a:srgbClr val="8B949E"/>
                 </a:solidFill>
@@ -4062,7 +4073,7 @@
           </a:p>
           <a:p>
             <a:r>
-              <a:rPr sz="1100">
+              <a:rPr sz="1000">
                 <a:solidFill>
                   <a:srgbClr val="8B949E"/>
                 </a:solidFill>
@@ -4073,7 +4084,7 @@
           </a:p>
           <a:p>
             <a:r>
-              <a:rPr sz="1100">
+              <a:rPr sz="1000">
                 <a:solidFill>
                   <a:srgbClr val="8B949E"/>
                 </a:solidFill>
@@ -4084,7 +4095,7 @@
           </a:p>
           <a:p>
             <a:r>
-              <a:rPr sz="1100">
+              <a:rPr sz="1000">
                 <a:solidFill>
                   <a:srgbClr val="8B949E"/>
                 </a:solidFill>
@@ -4095,7 +4106,7 @@
           </a:p>
           <a:p>
             <a:r>
-              <a:rPr sz="1100">
+              <a:rPr sz="1000">
                 <a:solidFill>
                   <a:srgbClr val="8B949E"/>
                 </a:solidFill>
@@ -4106,7 +4117,7 @@
           </a:p>
           <a:p>
             <a:r>
-              <a:rPr sz="1100">
+              <a:rPr sz="1000">
                 <a:solidFill>
                   <a:srgbClr val="8B949E"/>
                 </a:solidFill>
@@ -4117,7 +4128,7 @@
           </a:p>
           <a:p>
             <a:r>
-              <a:rPr sz="1100">
+              <a:rPr sz="1000">
                 <a:solidFill>
                   <a:srgbClr val="8B949E"/>
                 </a:solidFill>
@@ -4136,8 +4147,8 @@
         </p:nvSpPr>
         <p:spPr>
           <a:xfrm>
-            <a:off x="7772400" y="6217920"/>
-            <a:ext cx="1463040" cy="457200"/>
+            <a:off x="7772400" y="5120640"/>
+            <a:ext cx="6400800" cy="365760"/>
           </a:xfrm>
           <a:prstGeom prst="rect">
             <a:avLst/>
@@ -4150,28 +4161,754 @@
           </a:bodyPr>
           <a:lstStyle/>
           <a:p>
+            <a:r>
+              <a:rPr sz="1600" b="1">
+                <a:solidFill>
+                  <a:srgbClr val="FFA657"/>
+                </a:solidFill>
+              </a:rPr>
+              <a:t>Benchmark: L40S, Qwen3-0.6B, greedy, 32 tok</a:t>
+            </a:r>
+          </a:p>
+        </p:txBody>
+      </p:sp>
+      <p:sp>
+        <p:nvSpPr>
+          <p:cNvPr id="28" name="TextBox 27"/>
+          <p:cNvSpPr txBox="1"/>
+          <p:nvPr/>
+        </p:nvSpPr>
+        <p:spPr>
+          <a:xfrm>
+            <a:off x="7772400" y="5486400"/>
+            <a:ext cx="1280160" cy="201168"/>
+          </a:xfrm>
+          <a:prstGeom prst="rect">
+            <a:avLst/>
+          </a:prstGeom>
+          <a:noFill/>
+        </p:spPr>
+        <p:txBody>
+          <a:bodyPr wrap="none">
+            <a:spAutoFit/>
+          </a:bodyPr>
+          <a:lstStyle/>
+          <a:p>
+            <a:r>
+              <a:rPr sz="1000" b="1">
+                <a:solidFill>
+                  <a:srgbClr val="E6EDF3"/>
+                </a:solidFill>
+              </a:rPr>
+              <a:t>Requests</a:t>
+            </a:r>
+          </a:p>
+        </p:txBody>
+      </p:sp>
+      <p:sp>
+        <p:nvSpPr>
+          <p:cNvPr id="29" name="TextBox 28"/>
+          <p:cNvSpPr txBox="1"/>
+          <p:nvPr/>
+        </p:nvSpPr>
+        <p:spPr>
+          <a:xfrm>
+            <a:off x="9144000" y="5486400"/>
+            <a:ext cx="1280160" cy="201168"/>
+          </a:xfrm>
+          <a:prstGeom prst="rect">
+            <a:avLst/>
+          </a:prstGeom>
+          <a:noFill/>
+        </p:spPr>
+        <p:txBody>
+          <a:bodyPr wrap="none">
+            <a:spAutoFit/>
+          </a:bodyPr>
+          <a:lstStyle/>
+          <a:p>
+            <a:r>
+              <a:rPr sz="1000" b="1">
+                <a:solidFill>
+                  <a:srgbClr val="E6EDF3"/>
+                </a:solidFill>
+              </a:rPr>
+              <a:t>HF Serial</a:t>
+            </a:r>
+          </a:p>
+        </p:txBody>
+      </p:sp>
+      <p:sp>
+        <p:nvSpPr>
+          <p:cNvPr id="30" name="TextBox 29"/>
+          <p:cNvSpPr txBox="1"/>
+          <p:nvPr/>
+        </p:nvSpPr>
+        <p:spPr>
+          <a:xfrm>
+            <a:off x="10515600" y="5486400"/>
+            <a:ext cx="1280160" cy="201168"/>
+          </a:xfrm>
+          <a:prstGeom prst="rect">
+            <a:avLst/>
+          </a:prstGeom>
+          <a:noFill/>
+        </p:spPr>
+        <p:txBody>
+          <a:bodyPr wrap="none">
+            <a:spAutoFit/>
+          </a:bodyPr>
+          <a:lstStyle/>
+          <a:p>
+            <a:r>
+              <a:rPr sz="1000" b="1">
+                <a:solidFill>
+                  <a:srgbClr val="E6EDF3"/>
+                </a:solidFill>
+              </a:rPr>
+              <a:t>Batched</a:t>
+            </a:r>
+          </a:p>
+        </p:txBody>
+      </p:sp>
+      <p:sp>
+        <p:nvSpPr>
+          <p:cNvPr id="31" name="TextBox 30"/>
+          <p:cNvSpPr txBox="1"/>
+          <p:nvPr/>
+        </p:nvSpPr>
+        <p:spPr>
+          <a:xfrm>
+            <a:off x="11887200" y="5486400"/>
+            <a:ext cx="1280160" cy="201168"/>
+          </a:xfrm>
+          <a:prstGeom prst="rect">
+            <a:avLst/>
+          </a:prstGeom>
+          <a:noFill/>
+        </p:spPr>
+        <p:txBody>
+          <a:bodyPr wrap="none">
+            <a:spAutoFit/>
+          </a:bodyPr>
+          <a:lstStyle/>
+          <a:p>
+            <a:r>
+              <a:rPr sz="1000" b="1">
+                <a:solidFill>
+                  <a:srgbClr val="E6EDF3"/>
+                </a:solidFill>
+              </a:rPr>
+              <a:t>Speedup</a:t>
+            </a:r>
+          </a:p>
+        </p:txBody>
+      </p:sp>
+      <p:sp>
+        <p:nvSpPr>
+          <p:cNvPr id="32" name="TextBox 31"/>
+          <p:cNvSpPr txBox="1"/>
+          <p:nvPr/>
+        </p:nvSpPr>
+        <p:spPr>
+          <a:xfrm>
+            <a:off x="7772400" y="5687568"/>
+            <a:ext cx="1280160" cy="201168"/>
+          </a:xfrm>
+          <a:prstGeom prst="rect">
+            <a:avLst/>
+          </a:prstGeom>
+          <a:noFill/>
+        </p:spPr>
+        <p:txBody>
+          <a:bodyPr wrap="none">
+            <a:spAutoFit/>
+          </a:bodyPr>
+          <a:lstStyle/>
+          <a:p>
+            <a:r>
+              <a:rPr sz="1000">
+                <a:solidFill>
+                  <a:srgbClr val="8B949E"/>
+                </a:solidFill>
+              </a:rPr>
+              <a:t>1 req</a:t>
+            </a:r>
+          </a:p>
+        </p:txBody>
+      </p:sp>
+      <p:sp>
+        <p:nvSpPr>
+          <p:cNvPr id="33" name="TextBox 32"/>
+          <p:cNvSpPr txBox="1"/>
+          <p:nvPr/>
+        </p:nvSpPr>
+        <p:spPr>
+          <a:xfrm>
+            <a:off x="9144000" y="5687568"/>
+            <a:ext cx="1280160" cy="201168"/>
+          </a:xfrm>
+          <a:prstGeom prst="rect">
+            <a:avLst/>
+          </a:prstGeom>
+          <a:noFill/>
+        </p:spPr>
+        <p:txBody>
+          <a:bodyPr wrap="none">
+            <a:spAutoFit/>
+          </a:bodyPr>
+          <a:lstStyle/>
+          <a:p>
+            <a:r>
+              <a:rPr sz="1000">
+                <a:solidFill>
+                  <a:srgbClr val="8B949E"/>
+                </a:solidFill>
+              </a:rPr>
+              <a:t>58 tok/s</a:t>
+            </a:r>
+          </a:p>
+        </p:txBody>
+      </p:sp>
+      <p:sp>
+        <p:nvSpPr>
+          <p:cNvPr id="34" name="TextBox 33"/>
+          <p:cNvSpPr txBox="1"/>
+          <p:nvPr/>
+        </p:nvSpPr>
+        <p:spPr>
+          <a:xfrm>
+            <a:off x="10515600" y="5687568"/>
+            <a:ext cx="1280160" cy="201168"/>
+          </a:xfrm>
+          <a:prstGeom prst="rect">
+            <a:avLst/>
+          </a:prstGeom>
+          <a:noFill/>
+        </p:spPr>
+        <p:txBody>
+          <a:bodyPr wrap="none">
+            <a:spAutoFit/>
+          </a:bodyPr>
+          <a:lstStyle/>
+          <a:p>
+            <a:r>
+              <a:rPr sz="1000">
+                <a:solidFill>
+                  <a:srgbClr val="8B949E"/>
+                </a:solidFill>
+              </a:rPr>
+              <a:t>59 tok/s</a:t>
+            </a:r>
+          </a:p>
+        </p:txBody>
+      </p:sp>
+      <p:sp>
+        <p:nvSpPr>
+          <p:cNvPr id="35" name="TextBox 34"/>
+          <p:cNvSpPr txBox="1"/>
+          <p:nvPr/>
+        </p:nvSpPr>
+        <p:spPr>
+          <a:xfrm>
+            <a:off x="11887200" y="5687568"/>
+            <a:ext cx="1280160" cy="201168"/>
+          </a:xfrm>
+          <a:prstGeom prst="rect">
+            <a:avLst/>
+          </a:prstGeom>
+          <a:noFill/>
+        </p:spPr>
+        <p:txBody>
+          <a:bodyPr wrap="none">
+            <a:spAutoFit/>
+          </a:bodyPr>
+          <a:lstStyle/>
+          <a:p>
+            <a:r>
+              <a:rPr sz="1000">
+                <a:solidFill>
+                  <a:srgbClr val="8B949E"/>
+                </a:solidFill>
+              </a:rPr>
+              <a:t>1.0x</a:t>
+            </a:r>
+          </a:p>
+        </p:txBody>
+      </p:sp>
+      <p:sp>
+        <p:nvSpPr>
+          <p:cNvPr id="36" name="TextBox 35"/>
+          <p:cNvSpPr txBox="1"/>
+          <p:nvPr/>
+        </p:nvSpPr>
+        <p:spPr>
+          <a:xfrm>
+            <a:off x="7772400" y="5888736"/>
+            <a:ext cx="1280160" cy="201168"/>
+          </a:xfrm>
+          <a:prstGeom prst="rect">
+            <a:avLst/>
+          </a:prstGeom>
+          <a:noFill/>
+        </p:spPr>
+        <p:txBody>
+          <a:bodyPr wrap="none">
+            <a:spAutoFit/>
+          </a:bodyPr>
+          <a:lstStyle/>
+          <a:p>
+            <a:r>
+              <a:rPr sz="1000">
+                <a:solidFill>
+                  <a:srgbClr val="8B949E"/>
+                </a:solidFill>
+              </a:rPr>
+              <a:t>4 req</a:t>
+            </a:r>
+          </a:p>
+        </p:txBody>
+      </p:sp>
+      <p:sp>
+        <p:nvSpPr>
+          <p:cNvPr id="37" name="TextBox 36"/>
+          <p:cNvSpPr txBox="1"/>
+          <p:nvPr/>
+        </p:nvSpPr>
+        <p:spPr>
+          <a:xfrm>
+            <a:off x="9144000" y="5888736"/>
+            <a:ext cx="1280160" cy="201168"/>
+          </a:xfrm>
+          <a:prstGeom prst="rect">
+            <a:avLst/>
+          </a:prstGeom>
+          <a:noFill/>
+        </p:spPr>
+        <p:txBody>
+          <a:bodyPr wrap="none">
+            <a:spAutoFit/>
+          </a:bodyPr>
+          <a:lstStyle/>
+          <a:p>
+            <a:r>
+              <a:rPr sz="1000">
+                <a:solidFill>
+                  <a:srgbClr val="8B949E"/>
+                </a:solidFill>
+              </a:rPr>
+              <a:t>61 tok/s</a:t>
+            </a:r>
+          </a:p>
+        </p:txBody>
+      </p:sp>
+      <p:sp>
+        <p:nvSpPr>
+          <p:cNvPr id="38" name="TextBox 37"/>
+          <p:cNvSpPr txBox="1"/>
+          <p:nvPr/>
+        </p:nvSpPr>
+        <p:spPr>
+          <a:xfrm>
+            <a:off x="10515600" y="5888736"/>
+            <a:ext cx="1280160" cy="201168"/>
+          </a:xfrm>
+          <a:prstGeom prst="rect">
+            <a:avLst/>
+          </a:prstGeom>
+          <a:noFill/>
+        </p:spPr>
+        <p:txBody>
+          <a:bodyPr wrap="none">
+            <a:spAutoFit/>
+          </a:bodyPr>
+          <a:lstStyle/>
+          <a:p>
+            <a:r>
+              <a:rPr sz="1000" b="1">
+                <a:solidFill>
+                  <a:srgbClr val="7EE787"/>
+                </a:solidFill>
+              </a:rPr>
+              <a:t>212 tok/s</a:t>
+            </a:r>
+          </a:p>
+        </p:txBody>
+      </p:sp>
+      <p:sp>
+        <p:nvSpPr>
+          <p:cNvPr id="39" name="TextBox 38"/>
+          <p:cNvSpPr txBox="1"/>
+          <p:nvPr/>
+        </p:nvSpPr>
+        <p:spPr>
+          <a:xfrm>
+            <a:off x="11887200" y="5888736"/>
+            <a:ext cx="1280160" cy="201168"/>
+          </a:xfrm>
+          <a:prstGeom prst="rect">
+            <a:avLst/>
+          </a:prstGeom>
+          <a:noFill/>
+        </p:spPr>
+        <p:txBody>
+          <a:bodyPr wrap="none">
+            <a:spAutoFit/>
+          </a:bodyPr>
+          <a:lstStyle/>
+          <a:p>
+            <a:r>
+              <a:rPr sz="1000" b="1">
+                <a:solidFill>
+                  <a:srgbClr val="FFA657"/>
+                </a:solidFill>
+              </a:rPr>
+              <a:t>3.5x</a:t>
+            </a:r>
+          </a:p>
+        </p:txBody>
+      </p:sp>
+      <p:sp>
+        <p:nvSpPr>
+          <p:cNvPr id="40" name="TextBox 39"/>
+          <p:cNvSpPr txBox="1"/>
+          <p:nvPr/>
+        </p:nvSpPr>
+        <p:spPr>
+          <a:xfrm>
+            <a:off x="7772400" y="6089904"/>
+            <a:ext cx="1280160" cy="201168"/>
+          </a:xfrm>
+          <a:prstGeom prst="rect">
+            <a:avLst/>
+          </a:prstGeom>
+          <a:noFill/>
+        </p:spPr>
+        <p:txBody>
+          <a:bodyPr wrap="none">
+            <a:spAutoFit/>
+          </a:bodyPr>
+          <a:lstStyle/>
+          <a:p>
+            <a:r>
+              <a:rPr sz="1000">
+                <a:solidFill>
+                  <a:srgbClr val="8B949E"/>
+                </a:solidFill>
+              </a:rPr>
+              <a:t>8 req</a:t>
+            </a:r>
+          </a:p>
+        </p:txBody>
+      </p:sp>
+      <p:sp>
+        <p:nvSpPr>
+          <p:cNvPr id="41" name="TextBox 40"/>
+          <p:cNvSpPr txBox="1"/>
+          <p:nvPr/>
+        </p:nvSpPr>
+        <p:spPr>
+          <a:xfrm>
+            <a:off x="9144000" y="6089904"/>
+            <a:ext cx="1280160" cy="201168"/>
+          </a:xfrm>
+          <a:prstGeom prst="rect">
+            <a:avLst/>
+          </a:prstGeom>
+          <a:noFill/>
+        </p:spPr>
+        <p:txBody>
+          <a:bodyPr wrap="none">
+            <a:spAutoFit/>
+          </a:bodyPr>
+          <a:lstStyle/>
+          <a:p>
+            <a:r>
+              <a:rPr sz="1000">
+                <a:solidFill>
+                  <a:srgbClr val="8B949E"/>
+                </a:solidFill>
+              </a:rPr>
+              <a:t>59 tok/s</a:t>
+            </a:r>
+          </a:p>
+        </p:txBody>
+      </p:sp>
+      <p:sp>
+        <p:nvSpPr>
+          <p:cNvPr id="42" name="TextBox 41"/>
+          <p:cNvSpPr txBox="1"/>
+          <p:nvPr/>
+        </p:nvSpPr>
+        <p:spPr>
+          <a:xfrm>
+            <a:off x="10515600" y="6089904"/>
+            <a:ext cx="1280160" cy="201168"/>
+          </a:xfrm>
+          <a:prstGeom prst="rect">
+            <a:avLst/>
+          </a:prstGeom>
+          <a:noFill/>
+        </p:spPr>
+        <p:txBody>
+          <a:bodyPr wrap="none">
+            <a:spAutoFit/>
+          </a:bodyPr>
+          <a:lstStyle/>
+          <a:p>
+            <a:r>
+              <a:rPr sz="1000" b="1">
+                <a:solidFill>
+                  <a:srgbClr val="7EE787"/>
+                </a:solidFill>
+              </a:rPr>
+              <a:t>363 tok/s</a:t>
+            </a:r>
+          </a:p>
+        </p:txBody>
+      </p:sp>
+      <p:sp>
+        <p:nvSpPr>
+          <p:cNvPr id="43" name="TextBox 42"/>
+          <p:cNvSpPr txBox="1"/>
+          <p:nvPr/>
+        </p:nvSpPr>
+        <p:spPr>
+          <a:xfrm>
+            <a:off x="11887200" y="6089904"/>
+            <a:ext cx="1280160" cy="201168"/>
+          </a:xfrm>
+          <a:prstGeom prst="rect">
+            <a:avLst/>
+          </a:prstGeom>
+          <a:noFill/>
+        </p:spPr>
+        <p:txBody>
+          <a:bodyPr wrap="none">
+            <a:spAutoFit/>
+          </a:bodyPr>
+          <a:lstStyle/>
+          <a:p>
+            <a:r>
+              <a:rPr sz="1000" b="1">
+                <a:solidFill>
+                  <a:srgbClr val="FFA657"/>
+                </a:solidFill>
+              </a:rPr>
+              <a:t>6.1x</a:t>
+            </a:r>
+          </a:p>
+        </p:txBody>
+      </p:sp>
+      <p:sp>
+        <p:nvSpPr>
+          <p:cNvPr id="44" name="TextBox 43"/>
+          <p:cNvSpPr txBox="1"/>
+          <p:nvPr/>
+        </p:nvSpPr>
+        <p:spPr>
+          <a:xfrm>
+            <a:off x="7772400" y="6291072"/>
+            <a:ext cx="1280160" cy="201168"/>
+          </a:xfrm>
+          <a:prstGeom prst="rect">
+            <a:avLst/>
+          </a:prstGeom>
+          <a:noFill/>
+        </p:spPr>
+        <p:txBody>
+          <a:bodyPr wrap="none">
+            <a:spAutoFit/>
+          </a:bodyPr>
+          <a:lstStyle/>
+          <a:p>
+            <a:r>
+              <a:rPr sz="1000">
+                <a:solidFill>
+                  <a:srgbClr val="8B949E"/>
+                </a:solidFill>
+              </a:rPr>
+              <a:t>16 req</a:t>
+            </a:r>
+          </a:p>
+        </p:txBody>
+      </p:sp>
+      <p:sp>
+        <p:nvSpPr>
+          <p:cNvPr id="45" name="TextBox 44"/>
+          <p:cNvSpPr txBox="1"/>
+          <p:nvPr/>
+        </p:nvSpPr>
+        <p:spPr>
+          <a:xfrm>
+            <a:off x="9144000" y="6291072"/>
+            <a:ext cx="1280160" cy="201168"/>
+          </a:xfrm>
+          <a:prstGeom prst="rect">
+            <a:avLst/>
+          </a:prstGeom>
+          <a:noFill/>
+        </p:spPr>
+        <p:txBody>
+          <a:bodyPr wrap="none">
+            <a:spAutoFit/>
+          </a:bodyPr>
+          <a:lstStyle/>
+          <a:p>
+            <a:r>
+              <a:rPr sz="1000">
+                <a:solidFill>
+                  <a:srgbClr val="8B949E"/>
+                </a:solidFill>
+              </a:rPr>
+              <a:t>59 tok/s</a:t>
+            </a:r>
+          </a:p>
+        </p:txBody>
+      </p:sp>
+      <p:sp>
+        <p:nvSpPr>
+          <p:cNvPr id="46" name="TextBox 45"/>
+          <p:cNvSpPr txBox="1"/>
+          <p:nvPr/>
+        </p:nvSpPr>
+        <p:spPr>
+          <a:xfrm>
+            <a:off x="10515600" y="6291072"/>
+            <a:ext cx="1280160" cy="201168"/>
+          </a:xfrm>
+          <a:prstGeom prst="rect">
+            <a:avLst/>
+          </a:prstGeom>
+          <a:noFill/>
+        </p:spPr>
+        <p:txBody>
+          <a:bodyPr wrap="none">
+            <a:spAutoFit/>
+          </a:bodyPr>
+          <a:lstStyle/>
+          <a:p>
+            <a:r>
+              <a:rPr sz="1000" b="1">
+                <a:solidFill>
+                  <a:srgbClr val="7EE787"/>
+                </a:solidFill>
+              </a:rPr>
+              <a:t>526 tok/s</a:t>
+            </a:r>
+          </a:p>
+        </p:txBody>
+      </p:sp>
+      <p:sp>
+        <p:nvSpPr>
+          <p:cNvPr id="47" name="TextBox 46"/>
+          <p:cNvSpPr txBox="1"/>
+          <p:nvPr/>
+        </p:nvSpPr>
+        <p:spPr>
+          <a:xfrm>
+            <a:off x="11887200" y="6291072"/>
+            <a:ext cx="1280160" cy="201168"/>
+          </a:xfrm>
+          <a:prstGeom prst="rect">
+            <a:avLst/>
+          </a:prstGeom>
+          <a:noFill/>
+        </p:spPr>
+        <p:txBody>
+          <a:bodyPr wrap="none">
+            <a:spAutoFit/>
+          </a:bodyPr>
+          <a:lstStyle/>
+          <a:p>
+            <a:r>
+              <a:rPr sz="1000" b="1">
+                <a:solidFill>
+                  <a:srgbClr val="FFA657"/>
+                </a:solidFill>
+              </a:rPr>
+              <a:t>9.0x</a:t>
+            </a:r>
+          </a:p>
+        </p:txBody>
+      </p:sp>
+      <p:sp>
+        <p:nvSpPr>
+          <p:cNvPr id="48" name="TextBox 47"/>
+          <p:cNvSpPr txBox="1"/>
+          <p:nvPr/>
+        </p:nvSpPr>
+        <p:spPr>
+          <a:xfrm>
+            <a:off x="7772400" y="6537960"/>
+            <a:ext cx="6400800" cy="228600"/>
+          </a:xfrm>
+          <a:prstGeom prst="rect">
+            <a:avLst/>
+          </a:prstGeom>
+          <a:noFill/>
+        </p:spPr>
+        <p:txBody>
+          <a:bodyPr wrap="none">
+            <a:spAutoFit/>
+          </a:bodyPr>
+          <a:lstStyle/>
+          <a:p>
+            <a:r>
+              <a:rPr sz="1100" b="1">
+                <a:solidFill>
+                  <a:srgbClr val="7EE787"/>
+                </a:solidFill>
+              </a:rPr>
+              <a:t>Correctness: token-for-token IDENTICAL to HF model.generate()</a:t>
+            </a:r>
+          </a:p>
+        </p:txBody>
+      </p:sp>
+      <p:sp>
+        <p:nvSpPr>
+          <p:cNvPr id="49" name="TextBox 48"/>
+          <p:cNvSpPr txBox="1"/>
+          <p:nvPr/>
+        </p:nvSpPr>
+        <p:spPr>
+          <a:xfrm>
+            <a:off x="7772400" y="6858000"/>
+            <a:ext cx="1188720" cy="365760"/>
+          </a:xfrm>
+          <a:prstGeom prst="rect">
+            <a:avLst/>
+          </a:prstGeom>
+          <a:noFill/>
+        </p:spPr>
+        <p:txBody>
+          <a:bodyPr wrap="none">
+            <a:spAutoFit/>
+          </a:bodyPr>
+          <a:lstStyle/>
+          <a:p>
             <a:pPr algn="ctr"/>
             <a:r>
-              <a:rPr sz="2800" b="1">
+              <a:rPr sz="2400" b="1">
                 <a:solidFill>
                   <a:srgbClr val="7EE787"/>
                 </a:solidFill>
               </a:rPr>
-              <a:t>3,654</a:t>
-            </a:r>
-          </a:p>
-        </p:txBody>
-      </p:sp>
-      <p:sp>
-        <p:nvSpPr>
-          <p:cNvPr id="28" name="TextBox 27"/>
-          <p:cNvSpPr txBox="1"/>
-          <p:nvPr/>
-        </p:nvSpPr>
-        <p:spPr>
-          <a:xfrm>
-            <a:off x="7772400" y="6629400"/>
-            <a:ext cx="1463040" cy="274320"/>
+              <a:t>4,015</a:t>
+            </a:r>
+          </a:p>
+        </p:txBody>
+      </p:sp>
+      <p:sp>
+        <p:nvSpPr>
+          <p:cNvPr id="50" name="TextBox 49"/>
+          <p:cNvSpPr txBox="1"/>
+          <p:nvPr/>
+        </p:nvSpPr>
+        <p:spPr>
+          <a:xfrm>
+            <a:off x="7772400" y="7205472"/>
+            <a:ext cx="1188720" cy="228600"/>
           </a:xfrm>
           <a:prstGeom prst="rect">
             <a:avLst/>
@@ -4186,7 +4923,7 @@
           <a:p>
             <a:pPr algn="ctr"/>
             <a:r>
-              <a:rPr sz="1100">
+              <a:rPr sz="900">
                 <a:solidFill>
                   <a:srgbClr val="8B949E"/>
                 </a:solidFill>
@@ -4198,14 +4935,14 @@
       </p:sp>
       <p:sp>
         <p:nvSpPr>
-          <p:cNvPr id="29" name="TextBox 28"/>
-          <p:cNvSpPr txBox="1"/>
-          <p:nvPr/>
-        </p:nvSpPr>
-        <p:spPr>
-          <a:xfrm>
-            <a:off x="9418320" y="6217920"/>
-            <a:ext cx="1463040" cy="457200"/>
+          <p:cNvPr id="51" name="TextBox 50"/>
+          <p:cNvSpPr txBox="1"/>
+          <p:nvPr/>
+        </p:nvSpPr>
+        <p:spPr>
+          <a:xfrm>
+            <a:off x="9052560" y="6858000"/>
+            <a:ext cx="1188720" cy="365760"/>
           </a:xfrm>
           <a:prstGeom prst="rect">
             <a:avLst/>
@@ -4220,26 +4957,26 @@
           <a:p>
             <a:pPr algn="ctr"/>
             <a:r>
-              <a:rPr sz="2800" b="1">
+              <a:rPr sz="2400" b="1">
                 <a:solidFill>
                   <a:srgbClr val="58A6FF"/>
                 </a:solidFill>
               </a:rPr>
-              <a:t>2,578</a:t>
-            </a:r>
-          </a:p>
-        </p:txBody>
-      </p:sp>
-      <p:sp>
-        <p:nvSpPr>
-          <p:cNvPr id="30" name="TextBox 29"/>
-          <p:cNvSpPr txBox="1"/>
-          <p:nvPr/>
-        </p:nvSpPr>
-        <p:spPr>
-          <a:xfrm>
-            <a:off x="9418320" y="6629400"/>
-            <a:ext cx="1463040" cy="274320"/>
+              <a:t>3,506</a:t>
+            </a:r>
+          </a:p>
+        </p:txBody>
+      </p:sp>
+      <p:sp>
+        <p:nvSpPr>
+          <p:cNvPr id="52" name="TextBox 51"/>
+          <p:cNvSpPr txBox="1"/>
+          <p:nvPr/>
+        </p:nvSpPr>
+        <p:spPr>
+          <a:xfrm>
+            <a:off x="9052560" y="7205472"/>
+            <a:ext cx="1188720" cy="228600"/>
           </a:xfrm>
           <a:prstGeom prst="rect">
             <a:avLst/>
@@ -4254,7 +4991,7 @@
           <a:p>
             <a:pPr algn="ctr"/>
             <a:r>
-              <a:rPr sz="1100">
+              <a:rPr sz="900">
                 <a:solidFill>
                   <a:srgbClr val="8B949E"/>
                 </a:solidFill>
@@ -4266,14 +5003,14 @@
       </p:sp>
       <p:sp>
         <p:nvSpPr>
-          <p:cNvPr id="31" name="TextBox 30"/>
-          <p:cNvSpPr txBox="1"/>
-          <p:nvPr/>
-        </p:nvSpPr>
-        <p:spPr>
-          <a:xfrm>
-            <a:off x="11064240" y="6217920"/>
-            <a:ext cx="1463040" cy="457200"/>
+          <p:cNvPr id="53" name="TextBox 52"/>
+          <p:cNvSpPr txBox="1"/>
+          <p:nvPr/>
+        </p:nvSpPr>
+        <p:spPr>
+          <a:xfrm>
+            <a:off x="10332720" y="6858000"/>
+            <a:ext cx="1188720" cy="365760"/>
           </a:xfrm>
           <a:prstGeom prst="rect">
             <a:avLst/>
@@ -4288,7 +5025,7 @@
           <a:p>
             <a:pPr algn="ctr"/>
             <a:r>
-              <a:rPr sz="2800" b="1">
+              <a:rPr sz="2400" b="1">
                 <a:solidFill>
                   <a:srgbClr val="D2A8FF"/>
                 </a:solidFill>
@@ -4300,14 +5037,14 @@
       </p:sp>
       <p:sp>
         <p:nvSpPr>
-          <p:cNvPr id="32" name="TextBox 31"/>
-          <p:cNvSpPr txBox="1"/>
-          <p:nvPr/>
-        </p:nvSpPr>
-        <p:spPr>
-          <a:xfrm>
-            <a:off x="11064240" y="6629400"/>
-            <a:ext cx="1463040" cy="274320"/>
+          <p:cNvPr id="54" name="TextBox 53"/>
+          <p:cNvSpPr txBox="1"/>
+          <p:nvPr/>
+        </p:nvSpPr>
+        <p:spPr>
+          <a:xfrm>
+            <a:off x="10332720" y="7205472"/>
+            <a:ext cx="1188720" cy="228600"/>
           </a:xfrm>
           <a:prstGeom prst="rect">
             <a:avLst/>
@@ -4322,7 +5059,7 @@
           <a:p>
             <a:pPr algn="ctr"/>
             <a:r>
-              <a:rPr sz="1100">
+              <a:rPr sz="900">
                 <a:solidFill>
                   <a:srgbClr val="8B949E"/>
                 </a:solidFill>
@@ -4334,14 +5071,14 @@
       </p:sp>
       <p:sp>
         <p:nvSpPr>
-          <p:cNvPr id="33" name="TextBox 32"/>
-          <p:cNvSpPr txBox="1"/>
-          <p:nvPr/>
-        </p:nvSpPr>
-        <p:spPr>
-          <a:xfrm>
-            <a:off x="12710160" y="6217920"/>
-            <a:ext cx="1463040" cy="457200"/>
+          <p:cNvPr id="55" name="TextBox 54"/>
+          <p:cNvSpPr txBox="1"/>
+          <p:nvPr/>
+        </p:nvSpPr>
+        <p:spPr>
+          <a:xfrm>
+            <a:off x="11612879" y="6858000"/>
+            <a:ext cx="1188720" cy="365760"/>
           </a:xfrm>
           <a:prstGeom prst="rect">
             <a:avLst/>
@@ -4356,26 +5093,26 @@
           <a:p>
             <a:pPr algn="ctr"/>
             <a:r>
-              <a:rPr sz="2800" b="1">
+              <a:rPr sz="2400" b="1">
                 <a:solidFill>
                   <a:srgbClr val="FFA657"/>
                 </a:solidFill>
               </a:rPr>
-              <a:t>206</a:t>
-            </a:r>
-          </a:p>
-        </p:txBody>
-      </p:sp>
-      <p:sp>
-        <p:nvSpPr>
-          <p:cNvPr id="34" name="TextBox 33"/>
-          <p:cNvSpPr txBox="1"/>
-          <p:nvPr/>
-        </p:nvSpPr>
-        <p:spPr>
-          <a:xfrm>
-            <a:off x="12710160" y="6629400"/>
-            <a:ext cx="1463040" cy="274320"/>
+              <a:t>262</a:t>
+            </a:r>
+          </a:p>
+        </p:txBody>
+      </p:sp>
+      <p:sp>
+        <p:nvSpPr>
+          <p:cNvPr id="56" name="TextBox 55"/>
+          <p:cNvSpPr txBox="1"/>
+          <p:nvPr/>
+        </p:nvSpPr>
+        <p:spPr>
+          <a:xfrm>
+            <a:off x="11612879" y="7205472"/>
+            <a:ext cx="1188720" cy="228600"/>
           </a:xfrm>
           <a:prstGeom prst="rect">
             <a:avLst/>
@@ -4390,7 +5127,7 @@
           <a:p>
             <a:pPr algn="ctr"/>
             <a:r>
-              <a:rPr sz="1100">
+              <a:rPr sz="900">
                 <a:solidFill>
                   <a:srgbClr val="8B949E"/>
                 </a:solidFill>
@@ -4402,40 +5139,75 @@
       </p:sp>
       <p:sp>
         <p:nvSpPr>
-          <p:cNvPr id="35" name="TextBox 34"/>
-          <p:cNvSpPr txBox="1"/>
-          <p:nvPr/>
-        </p:nvSpPr>
-        <p:spPr>
-          <a:xfrm>
-            <a:off x="7772400" y="7132320"/>
-            <a:ext cx="6400800" cy="731520"/>
-          </a:xfrm>
-          <a:prstGeom prst="rect">
-            <a:avLst/>
-          </a:prstGeom>
-          <a:noFill/>
-        </p:spPr>
-        <p:txBody>
-          <a:bodyPr wrap="square">
-            <a:spAutoFit/>
-          </a:bodyPr>
-          <a:lstStyle/>
-          <a:p>
-            <a:r>
-              <a:rPr sz="1000" i="1">
-                <a:solidFill>
-                  <a:srgbClr val="6B747E"/>
-                </a:solidFill>
-              </a:rPr>
-              <a:t>Removed: TensorRT compilation, speculative decoding, disaggregated serving, pipeline parallelism, LoRA, quantization, beam search, multimodal, 25+ architectures, C++ bindings</a:t>
-            </a:r>
-          </a:p>
-        </p:txBody>
-      </p:sp>
-      <p:sp>
-        <p:nvSpPr>
-          <p:cNvPr id="36" name="TextBox 35"/>
+          <p:cNvPr id="57" name="TextBox 56"/>
+          <p:cNvSpPr txBox="1"/>
+          <p:nvPr/>
+        </p:nvSpPr>
+        <p:spPr>
+          <a:xfrm>
+            <a:off x="12893040" y="6858000"/>
+            <a:ext cx="1188720" cy="365760"/>
+          </a:xfrm>
+          <a:prstGeom prst="rect">
+            <a:avLst/>
+          </a:prstGeom>
+          <a:noFill/>
+        </p:spPr>
+        <p:txBody>
+          <a:bodyPr wrap="none">
+            <a:spAutoFit/>
+          </a:bodyPr>
+          <a:lstStyle/>
+          <a:p>
+            <a:pPr algn="ctr"/>
+            <a:r>
+              <a:rPr sz="2400" b="1">
+                <a:solidFill>
+                  <a:srgbClr val="FF6B6B"/>
+                </a:solidFill>
+              </a:rPr>
+              <a:t>9x</a:t>
+            </a:r>
+          </a:p>
+        </p:txBody>
+      </p:sp>
+      <p:sp>
+        <p:nvSpPr>
+          <p:cNvPr id="58" name="TextBox 57"/>
+          <p:cNvSpPr txBox="1"/>
+          <p:nvPr/>
+        </p:nvSpPr>
+        <p:spPr>
+          <a:xfrm>
+            <a:off x="12893040" y="7205472"/>
+            <a:ext cx="1188720" cy="228600"/>
+          </a:xfrm>
+          <a:prstGeom prst="rect">
+            <a:avLst/>
+          </a:prstGeom>
+          <a:noFill/>
+        </p:spPr>
+        <p:txBody>
+          <a:bodyPr wrap="none">
+            <a:spAutoFit/>
+          </a:bodyPr>
+          <a:lstStyle/>
+          <a:p>
+            <a:pPr algn="ctr"/>
+            <a:r>
+              <a:rPr sz="900">
+                <a:solidFill>
+                  <a:srgbClr val="8B949E"/>
+                </a:solidFill>
+              </a:rPr>
+              <a:t>Batch Speedup</a:t>
+            </a:r>
+          </a:p>
+        </p:txBody>
+      </p:sp>
+      <p:sp>
+        <p:nvSpPr>
+          <p:cNvPr id="59" name="TextBox 58"/>
           <p:cNvSpPr txBox="1"/>
           <p:nvPr/>
         </p:nvSpPr>

</xml_diff>